<commit_message>
Update pre-work slides to lead with the demand-forecasting + budget-optimization project
Replace the generic resume bullets on the fit slide with concrete
evidence from the PPC demand-forecasting/budget-optimization project
(ensemble forecasting, WMAPE/Tracking-Signal validation, moving-holiday
RCA, bias correction, response-curve budget allocation), and sharpen
the challenges/strategy slide with the same techniques.

Co-Authored-By: Claude Sonnet 5 <noreply@anthropic.com>
Claude-Session: https://claude.ai/code/session_01ESoLYaE7LNMYmpJtjY6qWy
</commit_message>
<xml_diff>
--- a/Agilent_Interview_Prework.pptx
+++ b/Agilent_Interview_Prework.pptx
@@ -1340,7 +1340,7 @@
                 <a:ea typeface="Calibri" pitchFamily="34" charset="-122"/>
                 <a:cs typeface="Calibri" pitchFamily="34" charset="-120"/>
               </a:rPr>
-              <a:t>Built an enterprise demand-forecasting engine</a:t>
+              <a:t>Built an end-to-end demand-forecasting + budget-optimization system</a:t>
             </a:r>
             <a:endParaRPr lang="en-US" sz="1450" dirty="0"/>
           </a:p>
@@ -1382,7 +1382,7 @@
                 <a:ea typeface="Calibri" pitchFamily="34" charset="-122"/>
                 <a:cs typeface="Calibri" pitchFamily="34" charset="-120"/>
               </a:rPr>
-              <a:t>LightGBM + SARIMAX + Statistical Top-Down ensemble (Huber-loss weighted) forecasting 12-month volumes across geographies and service/subject levels — a direct parallel to forecasting product orders across geographies.</a:t>
+              <a:t>4-model ensemble (Seasonal-Naive, Holt-Winters, Harmonic Regression, Global LightGBM) forecasting 12-month demand across 5 regions x 2 channels — 8.6% WMAPE, Tracking Signal in-control on 12-month walk-forward validation.</a:t>
             </a:r>
             <a:endParaRPr lang="en-US" sz="1150" dirty="0"/>
           </a:p>
@@ -1441,7 +1441,7 @@
                 <a:ea typeface="Calibri" pitchFamily="34" charset="-122"/>
                 <a:cs typeface="Calibri" pitchFamily="34" charset="-120"/>
               </a:rPr>
-              <a:t>Root-cause &amp; bias analysis that moved the needle</a:t>
+              <a:t>Root-cause diagnosis that fixed real accuracy gaps</a:t>
             </a:r>
             <a:endParaRPr lang="en-US" sz="1450" dirty="0"/>
           </a:p>
@@ -1483,7 +1483,7 @@
                 <a:ea typeface="Calibri" pitchFamily="34" charset="-122"/>
                 <a:cs typeface="Calibri" pitchFamily="34" charset="-120"/>
               </a:rPr>
-              <a:t>Diagnosed drivers of lead-conversion outcomes and lifted accuracy from 88% to 92% — the same rigor IBP forecast accuracy/bias reviews demand.</a:t>
+              <a:t>Traced highest-error regions to moving-holiday blind spots (Ramadan, CNY) and engineered event-intensity features to fix it — the exact RCA muscle needed for forecast accuracy/bias reviews with IBP planners.</a:t>
             </a:r>
             <a:endParaRPr lang="en-US" sz="1150" dirty="0"/>
           </a:p>
@@ -1542,7 +1542,7 @@
                 <a:ea typeface="Calibri" pitchFamily="34" charset="-122"/>
                 <a:cs typeface="Calibri" pitchFamily="34" charset="-120"/>
               </a:rPr>
-              <a:t>Models that stay in production, not slideware</a:t>
+              <a:t>Built the correction layer a demand planner would build by hand</a:t>
             </a:r>
             <a:endParaRPr lang="en-US" sz="1450" dirty="0"/>
           </a:p>
@@ -1584,7 +1584,7 @@
                 <a:ea typeface="Calibri" pitchFamily="34" charset="-122"/>
                 <a:cs typeface="Calibri" pitchFamily="34" charset="-120"/>
               </a:rPr>
-              <a:t>Turn statistical models into auto-refreshed pipelines (Microsoft Fabric ETL + Power BI) used company-wide — matches this role’s bar for data-model quality and refresh.</a:t>
+              <a:t>A trailing bias-correction step recalibrates against Tracking Signal automatically, validated identically in backtest and production — no gap between reported and deployed accuracy.</a:t>
             </a:r>
             <a:endParaRPr lang="en-US" sz="1150" dirty="0"/>
           </a:p>
@@ -1643,7 +1643,7 @@
                 <a:ea typeface="Calibri" pitchFamily="34" charset="-122"/>
                 <a:cs typeface="Calibri" pitchFamily="34" charset="-120"/>
               </a:rPr>
-              <a:t>Cross-functional &amp; executive partner</a:t>
+              <a:t>Translated forecasts into an allocation decision, not just a number</a:t>
             </a:r>
             <a:endParaRPr lang="en-US" sz="1450" dirty="0"/>
           </a:p>
@@ -1685,7 +1685,7 @@
                 <a:ea typeface="Calibri" pitchFamily="34" charset="-122"/>
                 <a:cs typeface="Calibri" pitchFamily="34" charset="-120"/>
               </a:rPr>
-              <a:t>Worked directly with Marketing, Sales, Customer Service and senior leadership to embed data-driven decisions — mirrors partnering with commercial, finance, and global operations.</a:t>
+              <a:t>Response-curve budget optimization turned a +25% budget into +15% output by respecting diminishing returns — the same logic that turns a demand forecast into a supply/inventory plan.</a:t>
             </a:r>
             <a:endParaRPr lang="en-US" sz="1150" dirty="0"/>
           </a:p>
@@ -1744,7 +1744,7 @@
                 <a:ea typeface="Calibri" pitchFamily="34" charset="-122"/>
                 <a:cs typeface="Calibri" pitchFamily="34" charset="-120"/>
               </a:rPr>
-              <a:t>Led and scaled analytics teams</a:t>
+              <a:t>Led teams and cross-functional partnerships at Cactus Communications</a:t>
             </a:r>
             <a:endParaRPr lang="en-US" sz="1450" dirty="0"/>
           </a:p>
@@ -1786,7 +1786,7 @@
                 <a:ea typeface="Calibri" pitchFamily="34" charset="-122"/>
                 <a:cs typeface="Calibri" pitchFamily="34" charset="-120"/>
               </a:rPr>
-              <a:t>Managed delivery across multiple concurrent analytics programs — ready for the master-level, team-leadership scope of this role.</a:t>
+              <a:t>Managed analytics delivery while partnering with Marketing, Sales, and Customer Service to embed data-driven decisions — ready for this role’s commercial/finance/ops and team-leadership scope.</a:t>
             </a:r>
             <a:endParaRPr lang="en-US" sz="1150" dirty="0"/>
           </a:p>
@@ -2139,7 +2139,7 @@
                 <a:ea typeface="Calibri" pitchFamily="34" charset="-122"/>
                 <a:cs typeface="Calibri" pitchFamily="34" charset="-120"/>
               </a:rPr>
-              <a:t>Multi-model ensemble (ML + statistical) with automated bias / Forecast-Value-Add dashboards feeding monthly IBP deviation reviews.</a:t>
+              <a:t>Inverse-error-weighted ensemble + trailing bias-correction against Tracking Signal — the same architecture that held Tracking Signal in [-4,+4] across a 5-region, 12-month forecast.</a:t>
             </a:r>
             <a:endParaRPr lang="en-US" sz="1200" dirty="0"/>
           </a:p>
@@ -2304,7 +2304,7 @@
                 <a:ea typeface="Calibri" pitchFamily="34" charset="-122"/>
                 <a:cs typeface="Calibri" pitchFamily="34" charset="-120"/>
               </a:rPr>
-              <a:t>Unified, governed demand data model with automated quality checks and a scheduled refresh cadence.</a:t>
+              <a:t>Unified, governed demand data model with automated quality checks and a scheduled refresh cadence, plus explicit reconciliation whenever top-down and bottom-up forecasts disagree.</a:t>
             </a:r>
             <a:endParaRPr lang="en-US" sz="1200" dirty="0"/>
           </a:p>
@@ -2427,7 +2427,7 @@
                 <a:ea typeface="Calibri" pitchFamily="34" charset="-122"/>
                 <a:cs typeface="Calibri" pitchFamily="34" charset="-120"/>
               </a:rPr>
-              <a:t>Earning trust in statistical forecasts over judgment-driven forecasts during Agilent’s Ignite IBP transformation.</a:t>
+              <a:t>Regional/seasonal quirks — moving holidays, funding cycles, reshoring shifts — that a generic seasonal model misses.</a:t>
             </a:r>
             <a:endParaRPr lang="en-US" sz="1200" dirty="0"/>
           </a:p>
@@ -2469,7 +2469,7 @@
                 <a:ea typeface="Calibri" pitchFamily="34" charset="-122"/>
                 <a:cs typeface="Calibri" pitchFamily="34" charset="-120"/>
               </a:rPr>
-              <a:t>Transparent, explainable models plus regular sessions that educate commercial, finance, and ops stakeholders on the gains.</a:t>
+              <a:t>Calendar-aware, event-intensity features per geography, validated with 12-month walk-forward backtesting rather than a single holdout.</a:t>
             </a:r>
             <a:endParaRPr lang="en-US" sz="1200" dirty="0"/>
           </a:p>
@@ -2592,7 +2592,7 @@
                 <a:ea typeface="Calibri" pitchFamily="34" charset="-122"/>
                 <a:cs typeface="Calibri" pitchFamily="34" charset="-120"/>
               </a:rPr>
-              <a:t>Scaling models from pilot to enterprise production without breaking during an org-wide rollout.</a:t>
+              <a:t>Earning trust in statistical forecasts over judgment-driven forecasts during Agilent’s Ignite IBP transformation.</a:t>
             </a:r>
             <a:endParaRPr lang="en-US" sz="1200" dirty="0"/>
           </a:p>
@@ -2634,7 +2634,7 @@
                 <a:ea typeface="Calibri" pitchFamily="34" charset="-122"/>
                 <a:cs typeface="Calibri" pitchFamily="34" charset="-120"/>
               </a:rPr>
-              <a:t>Reusable, monitored pipelines with drift/accuracy alerts and documented playbooks for team continuity.</a:t>
+              <a:t>Transparent, explainable models (inverse-WMAPE weighting) plus plain-language sessions on 'why this forecast changed' for commercial, finance, and ops stakeholders.</a:t>
             </a:r>
             <a:endParaRPr lang="en-US" sz="1200" dirty="0"/>
           </a:p>

</xml_diff>

<commit_message>
Add Publication Intelligence and identity-resolution bullets to fit slide
Consolidate the four forecasting-project bullets on slide 1 into two
to make room, then add: (1) the Publication Intelligence & Commercial
Impact project, emphasizing the engineering work — automated Fabric
ETL pipelines and web-embedded Power BI exposing insights directly to
customers; (2) a shorter pointer on the underlying customer
identity-mapping resolution pipeline.

Co-Authored-By: Claude Sonnet 5 <noreply@anthropic.com>
Claude-Session: https://claude.ai/code/session_01ESoLYaE7LNMYmpJtjY6qWy
</commit_message>
<xml_diff>
--- a/Agilent_Interview_Prework.pptx
+++ b/Agilent_Interview_Prework.pptx
@@ -1340,7 +1340,7 @@
                 <a:ea typeface="Calibri" pitchFamily="34" charset="-122"/>
                 <a:cs typeface="Calibri" pitchFamily="34" charset="-120"/>
               </a:rPr>
-              <a:t>Built an end-to-end demand-forecasting + budget-optimization system</a:t>
+              <a:t>Built an end-to-end demand-forecasting engine</a:t>
             </a:r>
             <a:endParaRPr lang="en-US" sz="1450" dirty="0"/>
           </a:p>
@@ -1382,7 +1382,7 @@
                 <a:ea typeface="Calibri" pitchFamily="34" charset="-122"/>
                 <a:cs typeface="Calibri" pitchFamily="34" charset="-120"/>
               </a:rPr>
-              <a:t>4-model ensemble (Seasonal-Naive, Holt-Winters, Harmonic Regression, Global LightGBM) forecasting 12-month demand across 5 regions x 2 channels — 8.6% WMAPE, Tracking Signal in-control on 12-month walk-forward validation.</a:t>
+              <a:t>4-model ensemble (Seasonal-Naive, Holt-Winters, Harmonic Regression, Global LightGBM) forecasting 12-month demand across 5 regions x 2 channels — 8.6% WMAPE, Tracking Signal in-control, with root-cause fixes for moving-holiday blind spots (Ramadan, CNY).</a:t>
             </a:r>
             <a:endParaRPr lang="en-US" sz="1150" dirty="0"/>
           </a:p>
@@ -1441,7 +1441,7 @@
                 <a:ea typeface="Calibri" pitchFamily="34" charset="-122"/>
                 <a:cs typeface="Calibri" pitchFamily="34" charset="-120"/>
               </a:rPr>
-              <a:t>Root-cause diagnosis that fixed real accuracy gaps</a:t>
+              <a:t>Closed the loop from forecast to action</a:t>
             </a:r>
             <a:endParaRPr lang="en-US" sz="1450" dirty="0"/>
           </a:p>
@@ -1483,7 +1483,7 @@
                 <a:ea typeface="Calibri" pitchFamily="34" charset="-122"/>
                 <a:cs typeface="Calibri" pitchFamily="34" charset="-120"/>
               </a:rPr>
-              <a:t>Traced highest-error regions to moving-holiday blind spots (Ramadan, CNY) and engineered event-intensity features to fix it — the exact RCA muscle needed for forecast accuracy/bias reviews with IBP planners.</a:t>
+              <a:t>A trailing bias-correction layer recalibrates against Tracking Signal automatically — validated identically in backtest and production — then response-curve optimization turned a +25% budget into +15% output by respecting diminishing returns.</a:t>
             </a:r>
             <a:endParaRPr lang="en-US" sz="1150" dirty="0"/>
           </a:p>
@@ -1542,7 +1542,7 @@
                 <a:ea typeface="Calibri" pitchFamily="34" charset="-122"/>
                 <a:cs typeface="Calibri" pitchFamily="34" charset="-120"/>
               </a:rPr>
-              <a:t>Built the correction layer a demand planner would build by hand</a:t>
+              <a:t>Engineered a customer-facing publication-intelligence pipeline</a:t>
             </a:r>
             <a:endParaRPr lang="en-US" sz="1450" dirty="0"/>
           </a:p>
@@ -1584,7 +1584,7 @@
                 <a:ea typeface="Calibri" pitchFamily="34" charset="-122"/>
                 <a:cs typeface="Calibri" pitchFamily="34" charset="-120"/>
               </a:rPr>
-              <a:t>A trailing bias-correction step recalibrates against Tracking Signal automatically, validated identically in backtest and production — no gap between reported and deployed accuracy.</a:t>
+              <a:t>Built automated Microsoft Fabric ETL pipelines that turned publication data into customer-level research intelligence, then engineered web-embedded Power BI to expose it directly to customers — enabling hyper-personalized, context-aware recommendations for Marketing and Sales.</a:t>
             </a:r>
             <a:endParaRPr lang="en-US" sz="1150" dirty="0"/>
           </a:p>
@@ -1643,7 +1643,7 @@
                 <a:ea typeface="Calibri" pitchFamily="34" charset="-122"/>
                 <a:cs typeface="Calibri" pitchFamily="34" charset="-120"/>
               </a:rPr>
-              <a:t>Translated forecasts into an allocation decision, not just a number</a:t>
+              <a:t>Built the identity-resolution layer underneath it</a:t>
             </a:r>
             <a:endParaRPr lang="en-US" sz="1450" dirty="0"/>
           </a:p>
@@ -1685,7 +1685,7 @@
                 <a:ea typeface="Calibri" pitchFamily="34" charset="-122"/>
                 <a:cs typeface="Calibri" pitchFamily="34" charset="-120"/>
               </a:rPr>
-              <a:t>Response-curve budget optimization turned a +25% budget into +15% output by respecting diminishing returns — the same logic that turns a demand forecast into a supply/inventory plan.</a:t>
+              <a:t>An automated pipeline (Python + OpenAI embeddings + distance/name-matching) that resolved ambiguous author profiles and mapped external publication records back to internal client IDs.</a:t>
             </a:r>
             <a:endParaRPr lang="en-US" sz="1150" dirty="0"/>
           </a:p>

</xml_diff>

<commit_message>
Replace slide 2 point 3 with installed-base propensity/spend challenge
Swap the moving-holiday seasonal-quirk row for the installed-base
consumables/service revenue challenge, matching the deeper walkthrough
of the propensity + spend model discussed in interview prep.

Co-Authored-By: Claude Sonnet 5 <noreply@anthropic.com>
Claude-Session: https://claude.ai/code/session_01ESoLYaE7LNMYmpJtjY6qWy
</commit_message>
<xml_diff>
--- a/Agilent_Interview_Prework.pptx
+++ b/Agilent_Interview_Prework.pptx
@@ -2427,7 +2427,7 @@
                 <a:ea typeface="Calibri" pitchFamily="34" charset="-122"/>
                 <a:cs typeface="Calibri" pitchFamily="34" charset="-120"/>
               </a:rPr>
-              <a:t>Regional/seasonal quirks — moving holidays, funding cycles, reshoring shifts — that a generic seasonal model misses.</a:t>
+              <a:t>Over half of Agilent’s revenue — consumables and service — tracks installed-base utilization, not new instrument bookings.</a:t>
             </a:r>
             <a:endParaRPr lang="en-US" sz="1200" dirty="0"/>
           </a:p>
@@ -2469,7 +2469,7 @@
                 <a:ea typeface="Calibri" pitchFamily="34" charset="-122"/>
                 <a:cs typeface="Calibri" pitchFamily="34" charset="-120"/>
               </a:rPr>
-              <a:t>Calendar-aware, event-intensity features per geography, validated with 12-month walk-forward backtesting rather than a single holdout.</a:t>
+              <a:t>Cohort-based propensity + spend model per installed instrument (RFM + install-age features) forecasts this recurring demand separately from the new-bookings pipeline forecast.</a:t>
             </a:r>
             <a:endParaRPr lang="en-US" sz="1200" dirty="0"/>
           </a:p>

</xml_diff>

<commit_message>
Replace slide 2 point 4 with FVA / root-cause dashboard challenge
Swap the Ignite-IBP trust-building row for the Forecast Value Add
(FVA) / root-cause dashboard challenge, tying directly to the JD's
"investigate forecast accuracy, bias, and value add" language and to
the bias/root-cause work on the Inquiry Conversion Scoring model.

Co-Authored-By: Claude Sonnet 5 <noreply@anthropic.com>
Claude-Session: https://claude.ai/code/session_01ESoLYaE7LNMYmpJtjY6qWy
</commit_message>
<xml_diff>
--- a/Agilent_Interview_Prework.pptx
+++ b/Agilent_Interview_Prework.pptx
@@ -2592,7 +2592,7 @@
                 <a:ea typeface="Calibri" pitchFamily="34" charset="-122"/>
                 <a:cs typeface="Calibri" pitchFamily="34" charset="-120"/>
               </a:rPr>
-              <a:t>Earning trust in statistical forecasts over judgment-driven forecasts during Agilent’s Ignite IBP transformation.</a:t>
+              <a:t>IBP deviation reviews spend time guessing whether a miss was a model error, a sales override, or a genuine market surprise.</a:t>
             </a:r>
             <a:endParaRPr lang="en-US" sz="1200" dirty="0"/>
           </a:p>
@@ -2634,7 +2634,7 @@
                 <a:ea typeface="Calibri" pitchFamily="34" charset="-122"/>
                 <a:cs typeface="Calibri" pitchFamily="34" charset="-120"/>
               </a:rPr>
-              <a:t>Transparent, explainable models (inverse-WMAPE weighting) plus plain-language sessions on 'why this forecast changed' for commercial, finance, and ops stakeholders.</a:t>
+              <a:t>A Forecast Value Add (FVA) / root-cause dashboard decomposing each month's error by cause — the same bias/root-cause diagnosis I applied on the Inquiry Conversion Scoring model.</a:t>
             </a:r>
             <a:endParaRPr lang="en-US" sz="1200" dirty="0"/>
           </a:p>

</xml_diff>